<commit_message>
docs: update defense presentation
</commit_message>
<xml_diff>
--- a/docs/presentation/DDM501_Defense_15p_Demo13p_QA10p.pptx
+++ b/docs/presentation/DDM501_Defense_15p_Demo13p_QA10p.pptx
@@ -243,7 +243,7 @@
           <a:p>
             <a:fld id="{3EFD42F7-718C-4B98-AAEC-167E6DDD60A7}" type="datetimeFigureOut">
               <a:rPr lang="en-US" smtClean="0"/>
-              <a:t>2026-10-03</a:t>
+              <a:t>2026-10-04</a:t>
             </a:fld>
             <a:endParaRPr lang="en-US"/>
           </a:p>
@@ -4166,7 +4166,7 @@
           <a:p>
             <a:fld id="{760FBDFE-C587-4B4C-A407-44438C67B59E}" type="datetimeFigureOut">
               <a:rPr lang="en-US" smtClean="0"/>
-              <a:t>2026-10-03</a:t>
+              <a:t>2026-10-04</a:t>
             </a:fld>
             <a:endParaRPr lang="en-US"/>
           </a:p>
@@ -4265,7 +4265,7 @@
           <a:p>
             <a:fld id="{760FBDFE-C587-4B4C-A407-44438C67B59E}" type="datetimeFigureOut">
               <a:rPr lang="en-US" smtClean="0"/>
-              <a:t>2026-10-03</a:t>
+              <a:t>2026-10-04</a:t>
             </a:fld>
             <a:endParaRPr lang="en-US"/>
           </a:p>
@@ -4423,7 +4423,7 @@
           <a:p>
             <a:fld id="{760FBDFE-C587-4B4C-A407-44438C67B59E}" type="datetimeFigureOut">
               <a:rPr lang="en-US" smtClean="0"/>
-              <a:t>2026-10-03</a:t>
+              <a:t>2026-10-04</a:t>
             </a:fld>
             <a:endParaRPr lang="en-US"/>
           </a:p>
@@ -4694,7 +4694,7 @@
           <a:p>
             <a:fld id="{760FBDFE-C587-4B4C-A407-44438C67B59E}" type="datetimeFigureOut">
               <a:rPr lang="en-US" smtClean="0"/>
-              <a:t>2026-10-03</a:t>
+              <a:t>2026-10-04</a:t>
             </a:fld>
             <a:endParaRPr lang="en-US"/>
           </a:p>
@@ -4954,7 +4954,7 @@
           <a:p>
             <a:fld id="{760FBDFE-C587-4B4C-A407-44438C67B59E}" type="datetimeFigureOut">
               <a:rPr lang="en-US" smtClean="0"/>
-              <a:t>2026-10-03</a:t>
+              <a:t>2026-10-04</a:t>
             </a:fld>
             <a:endParaRPr lang="en-US"/>
           </a:p>
@@ -5208,7 +5208,7 @@
           <a:p>
             <a:fld id="{760FBDFE-C587-4B4C-A407-44438C67B59E}" type="datetimeFigureOut">
               <a:rPr lang="en-US" smtClean="0"/>
-              <a:t>2026-10-03</a:t>
+              <a:t>2026-10-04</a:t>
             </a:fld>
             <a:endParaRPr lang="en-US"/>
           </a:p>
@@ -5622,7 +5622,7 @@
           <a:p>
             <a:fld id="{760FBDFE-C587-4B4C-A407-44438C67B59E}" type="datetimeFigureOut">
               <a:rPr lang="en-US" smtClean="0"/>
-              <a:t>2026-10-03</a:t>
+              <a:t>2026-10-04</a:t>
             </a:fld>
             <a:endParaRPr lang="en-US"/>
           </a:p>
@@ -5754,7 +5754,7 @@
           <a:p>
             <a:fld id="{760FBDFE-C587-4B4C-A407-44438C67B59E}" type="datetimeFigureOut">
               <a:rPr lang="en-US" smtClean="0"/>
-              <a:t>2026-10-03</a:t>
+              <a:t>2026-10-04</a:t>
             </a:fld>
             <a:endParaRPr lang="en-US"/>
           </a:p>
@@ -5853,7 +5853,7 @@
           <a:p>
             <a:fld id="{760FBDFE-C587-4B4C-A407-44438C67B59E}" type="datetimeFigureOut">
               <a:rPr lang="en-US" smtClean="0"/>
-              <a:t>2026-10-03</a:t>
+              <a:t>2026-10-04</a:t>
             </a:fld>
             <a:endParaRPr lang="en-US"/>
           </a:p>
@@ -6025,7 +6025,7 @@
           <a:p>
             <a:fld id="{9EFD9D74-47D9-4702-A33C-335B63B48DBF}" type="datetimeFigureOut">
               <a:rPr lang="en-US" smtClean="0"/>
-              <a:t>2026-10-03</a:t>
+              <a:t>2026-10-04</a:t>
             </a:fld>
             <a:endParaRPr lang="en-US" dirty="0"/>
           </a:p>
@@ -6265,7 +6265,7 @@
           <a:p>
             <a:fld id="{760FBDFE-C587-4B4C-A407-44438C67B59E}" type="datetimeFigureOut">
               <a:rPr lang="en-US" smtClean="0"/>
-              <a:t>2026-10-03</a:t>
+              <a:t>2026-10-04</a:t>
             </a:fld>
             <a:endParaRPr lang="en-US"/>
           </a:p>
@@ -6488,7 +6488,7 @@
           <a:p>
             <a:fld id="{760FBDFE-C587-4B4C-A407-44438C67B59E}" type="datetimeFigureOut">
               <a:rPr lang="en-US" smtClean="0"/>
-              <a:t>2026-10-03</a:t>
+              <a:t>2026-10-04</a:t>
             </a:fld>
             <a:endParaRPr lang="en-US"/>
           </a:p>
@@ -10003,7 +10003,7 @@
               <a:buNone/>
             </a:pPr>
             <a:r>
-              <a:rPr lang="vi-VN" sz="2400" b="1">
+              <a:rPr lang="vi-VN" sz="2600" b="1">
                 <a:solidFill>
                   <a:srgbClr val="172F3C"/>
                 </a:solidFill>
@@ -11611,7 +11611,7 @@
               <a:buNone/>
             </a:pPr>
             <a:r>
-              <a:rPr lang="vi-VN" sz="2400" b="1">
+              <a:rPr lang="vi-VN" sz="2800" b="1">
                 <a:solidFill>
                   <a:srgbClr val="172F3C"/>
                 </a:solidFill>
@@ -12984,7 +12984,7 @@
               <a:buNone/>
             </a:pPr>
             <a:r>
-              <a:rPr lang="vi-VN" sz="2400" b="1">
+              <a:rPr lang="vi-VN" sz="2800" b="1">
                 <a:solidFill>
                   <a:srgbClr val="172F3C"/>
                 </a:solidFill>
@@ -13660,7 +13660,7 @@
               <a:buNone/>
             </a:pPr>
             <a:r>
-              <a:rPr lang="vi-VN" sz="2400" b="1">
+              <a:rPr lang="vi-VN" sz="2800" b="1">
                 <a:solidFill>
                   <a:srgbClr val="172F3C"/>
                 </a:solidFill>
@@ -26610,14 +26610,14 @@
               <a:buNone/>
             </a:pPr>
             <a:r>
-              <a:rPr lang="vi-VN" sz="3200" b="1">
+              <a:rPr lang="vi-VN" sz="2800" b="1">
                 <a:solidFill>
                   <a:srgbClr val="172F3C"/>
                 </a:solidFill>
                 <a:latin typeface="Segoe UI" panose="020B0502040204020203" charset="0"/>
                 <a:cs typeface="Segoe UI" panose="020B0502040204020203" charset="0"/>
               </a:rPr>
-              <a:t>Hệ thống kiểm tra những dấu hiệu nào?</a:t>
+              <a:t>HỆ THỐNG KIỂM TRA NHỮNG DẤU HIỆU NÀO?</a:t>
             </a:r>
           </a:p>
         </p:txBody>
@@ -27642,14 +27642,14 @@
               <a:buNone/>
             </a:pPr>
             <a:r>
-              <a:rPr lang="vi-VN" sz="3200" b="1">
+              <a:rPr lang="vi-VN" sz="2800" b="1">
                 <a:solidFill>
                   <a:srgbClr val="172F3C"/>
                 </a:solidFill>
                 <a:latin typeface="Segoe UI" panose="020B0502040204020203" charset="0"/>
                 <a:cs typeface="Segoe UI" panose="020B0502040204020203" charset="0"/>
               </a:rPr>
-              <a:t>Bổ sung xác minh vào phần mềm thi đang có</a:t>
+              <a:t>BỔ SUNG XÁC MINH VÀO PHẦN MỀM THI ĐANG CÓ</a:t>
             </a:r>
           </a:p>
         </p:txBody>
@@ -28023,7 +28023,7 @@
               <a:buNone/>
             </a:pPr>
             <a:r>
-              <a:rPr lang="vi-VN" sz="3200" b="1">
+              <a:rPr lang="vi-VN" sz="2800" b="1">
                 <a:solidFill>
                   <a:srgbClr val="172F3C"/>
                 </a:solidFill>

</xml_diff>